<commit_message>
Slides: sd-01-017 slide 6 says the five mandatory constraints
Slide 6 titled the list "Năm ràng buộc của REST" while slide 9 says Fielding
describes six, the sixth (code on demand) being optional. The title now reads
"Năm ràng buộc bắt buộc của REST", which matches the lesson. Slide 6 PNG and
the PPTX are re-exported from the same Moda canvas, badge kept; the other nine
PNG files are byte-identical.

Co-Authored-By: Claude Sonnet 5.5 <noreply@anthropic.com>
Claude-Session: https://claude.ai/code/session_01B3es2UUE2NUZWB229fkJMH
</commit_message>
<xml_diff>
--- a/system-design-101/vi/lessons/sd-01-017/slides/sd-01-017.pptx
+++ b/system-design-101/vi/lessons/sd-01-017/slides/sd-01-017.pptx
@@ -12780,6 +12780,28 @@
                 <a:cs typeface="Bricolage Grotesque ExtraBold" pitchFamily="34" charset="-120"/>
               </a:rPr>
               <a:t> ràng</a:t>
+            </a:r>
+            <a:r>
+              <a:rPr lang="en-US" sz="7800" dirty="0" spc="8" kern="0">
+                <a:solidFill>
+                  <a:srgbClr val="14161C"/>
+                </a:solidFill>
+                <a:latin typeface="Bricolage Grotesque ExtraBold" pitchFamily="34" charset="0"/>
+                <a:ea typeface="Bricolage Grotesque ExtraBold" pitchFamily="34" charset="-122"/>
+                <a:cs typeface="Bricolage Grotesque ExtraBold" pitchFamily="34" charset="-120"/>
+              </a:rPr>
+              <a:t> buộc</a:t>
+            </a:r>
+            <a:r>
+              <a:rPr lang="en-US" sz="7800" dirty="0" spc="-6" kern="0">
+                <a:solidFill>
+                  <a:srgbClr val="14161C"/>
+                </a:solidFill>
+                <a:latin typeface="Bricolage Grotesque ExtraBold" pitchFamily="34" charset="0"/>
+                <a:ea typeface="Bricolage Grotesque ExtraBold" pitchFamily="34" charset="-122"/>
+                <a:cs typeface="Bricolage Grotesque ExtraBold" pitchFamily="34" charset="-120"/>
+              </a:rPr>
+              <a:t> bắt</a:t>
             </a:r>
             <a:r>
               <a:rPr lang="en-US" sz="7800" dirty="0" spc="8" kern="0">

</xml_diff>